<commit_message>
Tidy the repository: config/, bib/, one asset folder per part
- Python scripts and main.json moved to config/ (build_all.bat updated).
- refs.bib moved to bib/ (main.json points to bib/refs.bib).
- Pictures and videos moved to assets/<part>/ (01-title ... 07-conclusion);
  illustrations.pptx stays at the root of assets/.
- Drawings of slides 9, 10 and 12 extracted from parts/05-physical.html to
  assets/05-physical/*.svg and included by the build (data-include), so their
  step CSS still applies. Standalone output is byte-identical except paths.
- illustrations.pptx: five slides added (17 in total) with the drawings of
  slides 9-12, same picture structure as the other drawings (PNG + SVG).
- Unused pictures removed (context3, cover2, pageBW, who_I_am, unused sota/*).

Co-Authored-By: Claude <noreply@anthropic.com>
Claude-Session: https://claude.ai/code/session_01Vb7PS6Yk3Yima81s9SqAcv
</commit_message>
<xml_diff>
--- a/assets/illustrations.pptx
+++ b/assets/illustrations.pptx
@@ -17,6 +17,11 @@
     <p:sldId id="265" r:id="rId11"/>
     <p:sldId id="266" r:id="rId12"/>
     <p:sldId id="267" r:id="rId13"/>
+    <p:sldId id="268" r:id="rId18"/>
+    <p:sldId id="269" r:id="rId19"/>
+    <p:sldId id="270" r:id="rId20"/>
+    <p:sldId id="271" r:id="rId21"/>
+    <p:sldId id="272" r:id="rId22"/>
   </p:sldIdLst>
   <p:sldSz cx="12192000" cy="6858000"/>
   <p:notesSz cx="6858000" cy="9144000"/>
@@ -4161,6 +4166,391 @@
         <p14:creationId xmlns:p14="http://schemas.microsoft.com/office/powerpoint/2010/main" val="2942038449"/>
       </p:ext>
     </p:extLst>
+  </p:cSld>
+  <p:clrMapOvr>
+    <a:masterClrMapping/>
+  </p:clrMapOvr>
+</p:sld>
+</file>
+
+<file path=ppt/slides/slide13.xml><?xml version="1.0" encoding="utf-8"?>
+<p:sld xmlns:a="http://schemas.openxmlformats.org/drawingml/2006/main" xmlns:p="http://schemas.openxmlformats.org/presentationml/2006/main" xmlns:r="http://schemas.openxmlformats.org/officeDocument/2006/relationships">
+  <p:cSld>
+    <p:spTree>
+      <p:nvGrpSpPr>
+        <p:cNvPr id="1" name=""/>
+        <p:cNvGrpSpPr/>
+        <p:nvPr/>
+      </p:nvGrpSpPr>
+      <p:grpSpPr/>
+      <p:sp>
+        <p:nvSpPr>
+          <p:cNvPr id="2" name="TextBox 1"/>
+          <p:cNvSpPr txBox="1"/>
+          <p:nvPr/>
+        </p:nvSpPr>
+        <p:spPr>
+          <a:xfrm>
+            <a:off x="457200" y="274320"/>
+            <a:ext cx="10972800" cy="731520"/>
+          </a:xfrm>
+          <a:prstGeom prst="rect">
+            <a:avLst/>
+          </a:prstGeom>
+          <a:noFill/>
+        </p:spPr>
+        <p:txBody>
+          <a:bodyPr wrap="square">
+            <a:spAutoFit/>
+          </a:bodyPr>
+          <a:lstStyle/>
+          <a:p>
+            <a:r>
+              <a:rPr sz="2400" b="1"/>
+              <a:t>assets/05-physical/governing.svg</a:t>
+            </a:r>
+          </a:p>
+        </p:txBody>
+      </p:sp>
+      <p:pic>
+        <p:nvPicPr>
+          <p:cNvPr id="3" name="Picture 2" descr="governing.svg"/>
+          <p:cNvPicPr>
+            <a:picLocks noChangeAspect="1"/>
+          </p:cNvPicPr>
+          <p:nvPr/>
+        </p:nvPicPr>
+        <p:blipFill>
+          <a:blip r:embed="rId2">
+            <a:extLst>
+              <a:ext uri="{96DAC541-7B7A-43D3-8B79-37D633B846F1}">
+                <asvg:svgBlip xmlns:asvg="http://schemas.microsoft.com/office/drawing/2016/SVG/main" r:embed="rId3"/>
+              </a:ext>
+            </a:extLst>
+          </a:blip>
+          <a:stretch>
+            <a:fillRect/>
+          </a:stretch>
+        </p:blipFill>
+        <p:spPr>
+          <a:xfrm>
+            <a:off x="4267200" y="1280160"/>
+            <a:ext cx="3657600" cy="5120640"/>
+          </a:xfrm>
+          <a:prstGeom prst="rect">
+            <a:avLst/>
+          </a:prstGeom>
+        </p:spPr>
+      </p:pic>
+    </p:spTree>
+  </p:cSld>
+  <p:clrMapOvr>
+    <a:masterClrMapping/>
+  </p:clrMapOvr>
+</p:sld>
+</file>
+
+<file path=ppt/slides/slide14.xml><?xml version="1.0" encoding="utf-8"?>
+<p:sld xmlns:a="http://schemas.openxmlformats.org/drawingml/2006/main" xmlns:p="http://schemas.openxmlformats.org/presentationml/2006/main" xmlns:r="http://schemas.openxmlformats.org/officeDocument/2006/relationships">
+  <p:cSld>
+    <p:spTree>
+      <p:nvGrpSpPr>
+        <p:cNvPr id="1" name=""/>
+        <p:cNvGrpSpPr/>
+        <p:nvPr/>
+      </p:nvGrpSpPr>
+      <p:grpSpPr/>
+      <p:sp>
+        <p:nvSpPr>
+          <p:cNvPr id="2" name="TextBox 1"/>
+          <p:cNvSpPr txBox="1"/>
+          <p:nvPr/>
+        </p:nvSpPr>
+        <p:spPr>
+          <a:xfrm>
+            <a:off x="457200" y="274320"/>
+            <a:ext cx="10972800" cy="731520"/>
+          </a:xfrm>
+          <a:prstGeom prst="rect">
+            <a:avLst/>
+          </a:prstGeom>
+          <a:noFill/>
+        </p:spPr>
+        <p:txBody>
+          <a:bodyPr wrap="square">
+            <a:spAutoFit/>
+          </a:bodyPr>
+          <a:lstStyle/>
+          <a:p>
+            <a:r>
+              <a:rPr sz="2400" b="1"/>
+              <a:t>assets/05-physical/external.svg</a:t>
+            </a:r>
+          </a:p>
+        </p:txBody>
+      </p:sp>
+      <p:pic>
+        <p:nvPicPr>
+          <p:cNvPr id="3" name="Picture 2" descr="external.svg"/>
+          <p:cNvPicPr>
+            <a:picLocks noChangeAspect="1"/>
+          </p:cNvPicPr>
+          <p:nvPr/>
+        </p:nvPicPr>
+        <p:blipFill>
+          <a:blip r:embed="rId2">
+            <a:extLst>
+              <a:ext uri="{96DAC541-7B7A-43D3-8B79-37D633B846F1}">
+                <asvg:svgBlip xmlns:asvg="http://schemas.microsoft.com/office/drawing/2016/SVG/main" r:embed="rId3"/>
+              </a:ext>
+            </a:extLst>
+          </a:blip>
+          <a:stretch>
+            <a:fillRect/>
+          </a:stretch>
+        </p:blipFill>
+        <p:spPr>
+          <a:xfrm>
+            <a:off x="3901440" y="1280160"/>
+            <a:ext cx="4389120" cy="5120640"/>
+          </a:xfrm>
+          <a:prstGeom prst="rect">
+            <a:avLst/>
+          </a:prstGeom>
+        </p:spPr>
+      </p:pic>
+    </p:spTree>
+  </p:cSld>
+  <p:clrMapOvr>
+    <a:masterClrMapping/>
+  </p:clrMapOvr>
+</p:sld>
+</file>
+
+<file path=ppt/slides/slide15.xml><?xml version="1.0" encoding="utf-8"?>
+<p:sld xmlns:a="http://schemas.openxmlformats.org/drawingml/2006/main" xmlns:p="http://schemas.openxmlformats.org/presentationml/2006/main" xmlns:r="http://schemas.openxmlformats.org/officeDocument/2006/relationships">
+  <p:cSld>
+    <p:spTree>
+      <p:nvGrpSpPr>
+        <p:cNvPr id="1" name=""/>
+        <p:cNvGrpSpPr/>
+        <p:nvPr/>
+      </p:nvGrpSpPr>
+      <p:grpSpPr/>
+      <p:sp>
+        <p:nvSpPr>
+          <p:cNvPr id="2" name="TextBox 1"/>
+          <p:cNvSpPr txBox="1"/>
+          <p:nvPr/>
+        </p:nvSpPr>
+        <p:spPr>
+          <a:xfrm>
+            <a:off x="457200" y="274320"/>
+            <a:ext cx="10972800" cy="731520"/>
+          </a:xfrm>
+          <a:prstGeom prst="rect">
+            <a:avLst/>
+          </a:prstGeom>
+          <a:noFill/>
+        </p:spPr>
+        <p:txBody>
+          <a:bodyPr wrap="square">
+            <a:spAutoFit/>
+          </a:bodyPr>
+          <a:lstStyle/>
+          <a:p>
+            <a:r>
+              <a:rPr sz="2400" b="1"/>
+              <a:t>assets/05-physical/radiation-sw.svg</a:t>
+            </a:r>
+          </a:p>
+        </p:txBody>
+      </p:sp>
+      <p:pic>
+        <p:nvPicPr>
+          <p:cNvPr id="3" name="Picture 2" descr="radiation-sw.svg"/>
+          <p:cNvPicPr>
+            <a:picLocks noChangeAspect="1"/>
+          </p:cNvPicPr>
+          <p:nvPr/>
+        </p:nvPicPr>
+        <p:blipFill>
+          <a:blip r:embed="rId2">
+            <a:extLst>
+              <a:ext uri="{96DAC541-7B7A-43D3-8B79-37D633B846F1}">
+                <asvg:svgBlip xmlns:asvg="http://schemas.microsoft.com/office/drawing/2016/SVG/main" r:embed="rId3"/>
+              </a:ext>
+            </a:extLst>
+          </a:blip>
+          <a:stretch>
+            <a:fillRect/>
+          </a:stretch>
+        </p:blipFill>
+        <p:spPr>
+          <a:xfrm>
+            <a:off x="2827506" y="1280160"/>
+            <a:ext cx="6536987" cy="5120640"/>
+          </a:xfrm>
+          <a:prstGeom prst="rect">
+            <a:avLst/>
+          </a:prstGeom>
+        </p:spPr>
+      </p:pic>
+    </p:spTree>
+  </p:cSld>
+  <p:clrMapOvr>
+    <a:masterClrMapping/>
+  </p:clrMapOvr>
+</p:sld>
+</file>
+
+<file path=ppt/slides/slide16.xml><?xml version="1.0" encoding="utf-8"?>
+<p:sld xmlns:a="http://schemas.openxmlformats.org/drawingml/2006/main" xmlns:p="http://schemas.openxmlformats.org/presentationml/2006/main" xmlns:r="http://schemas.openxmlformats.org/officeDocument/2006/relationships">
+  <p:cSld>
+    <p:spTree>
+      <p:nvGrpSpPr>
+        <p:cNvPr id="1" name=""/>
+        <p:cNvGrpSpPr/>
+        <p:nvPr/>
+      </p:nvGrpSpPr>
+      <p:grpSpPr/>
+      <p:sp>
+        <p:nvSpPr>
+          <p:cNvPr id="2" name="TextBox 1"/>
+          <p:cNvSpPr txBox="1"/>
+          <p:nvPr/>
+        </p:nvSpPr>
+        <p:spPr>
+          <a:xfrm>
+            <a:off x="457200" y="274320"/>
+            <a:ext cx="10972800" cy="731520"/>
+          </a:xfrm>
+          <a:prstGeom prst="rect">
+            <a:avLst/>
+          </a:prstGeom>
+          <a:noFill/>
+        </p:spPr>
+        <p:txBody>
+          <a:bodyPr wrap="square">
+            <a:spAutoFit/>
+          </a:bodyPr>
+          <a:lstStyle/>
+          <a:p>
+            <a:r>
+              <a:rPr sz="2400" b="1"/>
+              <a:t>assets/05-physical/radiation-lw.svg</a:t>
+            </a:r>
+          </a:p>
+        </p:txBody>
+      </p:sp>
+      <p:pic>
+        <p:nvPicPr>
+          <p:cNvPr id="3" name="Picture 2" descr="radiation-lw.svg"/>
+          <p:cNvPicPr>
+            <a:picLocks noChangeAspect="1"/>
+          </p:cNvPicPr>
+          <p:nvPr/>
+        </p:nvPicPr>
+        <p:blipFill>
+          <a:blip r:embed="rId2">
+            <a:extLst>
+              <a:ext uri="{96DAC541-7B7A-43D3-8B79-37D633B846F1}">
+                <asvg:svgBlip xmlns:asvg="http://schemas.microsoft.com/office/drawing/2016/SVG/main" r:embed="rId3"/>
+              </a:ext>
+            </a:extLst>
+          </a:blip>
+          <a:stretch>
+            <a:fillRect/>
+          </a:stretch>
+        </p:blipFill>
+        <p:spPr>
+          <a:xfrm>
+            <a:off x="2827506" y="1280160"/>
+            <a:ext cx="6536987" cy="5120640"/>
+          </a:xfrm>
+          <a:prstGeom prst="rect">
+            <a:avLst/>
+          </a:prstGeom>
+        </p:spPr>
+      </p:pic>
+    </p:spTree>
+  </p:cSld>
+  <p:clrMapOvr>
+    <a:masterClrMapping/>
+  </p:clrMapOvr>
+</p:sld>
+</file>
+
+<file path=ppt/slides/slide17.xml><?xml version="1.0" encoding="utf-8"?>
+<p:sld xmlns:a="http://schemas.openxmlformats.org/drawingml/2006/main" xmlns:p="http://schemas.openxmlformats.org/presentationml/2006/main" xmlns:r="http://schemas.openxmlformats.org/officeDocument/2006/relationships">
+  <p:cSld>
+    <p:spTree>
+      <p:nvGrpSpPr>
+        <p:cNvPr id="1" name=""/>
+        <p:cNvGrpSpPr/>
+        <p:nvPr/>
+      </p:nvGrpSpPr>
+      <p:grpSpPr/>
+      <p:sp>
+        <p:nvSpPr>
+          <p:cNvPr id="2" name="TextBox 1"/>
+          <p:cNvSpPr txBox="1"/>
+          <p:nvPr/>
+        </p:nvSpPr>
+        <p:spPr>
+          <a:xfrm>
+            <a:off x="457200" y="274320"/>
+            <a:ext cx="10972800" cy="731520"/>
+          </a:xfrm>
+          <a:prstGeom prst="rect">
+            <a:avLst/>
+          </a:prstGeom>
+          <a:noFill/>
+        </p:spPr>
+        <p:txBody>
+          <a:bodyPr wrap="square">
+            <a:spAutoFit/>
+          </a:bodyPr>
+          <a:lstStyle/>
+          <a:p>
+            <a:r>
+              <a:rPr sz="2400" b="1"/>
+              <a:t>assets/05-physical/internal.svg</a:t>
+            </a:r>
+          </a:p>
+        </p:txBody>
+      </p:sp>
+      <p:pic>
+        <p:nvPicPr>
+          <p:cNvPr id="3" name="Picture 2" descr="internal.svg"/>
+          <p:cNvPicPr>
+            <a:picLocks noChangeAspect="1"/>
+          </p:cNvPicPr>
+          <p:nvPr/>
+        </p:nvPicPr>
+        <p:blipFill>
+          <a:blip r:embed="rId2">
+            <a:extLst>
+              <a:ext uri="{96DAC541-7B7A-43D3-8B79-37D633B846F1}">
+                <asvg:svgBlip xmlns:asvg="http://schemas.microsoft.com/office/drawing/2016/SVG/main" r:embed="rId3"/>
+              </a:ext>
+            </a:extLst>
+          </a:blip>
+          <a:stretch>
+            <a:fillRect/>
+          </a:stretch>
+        </p:blipFill>
+        <p:spPr>
+          <a:xfrm>
+            <a:off x="3580598" y="1280160"/>
+            <a:ext cx="5030804" cy="5120640"/>
+          </a:xfrm>
+          <a:prstGeom prst="rect">
+            <a:avLst/>
+          </a:prstGeom>
+        </p:spPr>
+      </p:pic>
+    </p:spTree>
   </p:cSld>
   <p:clrMapOvr>
     <a:masterClrMapping/>

</xml_diff>

<commit_message>
Fix inline drawings with a leading comment; point illustrations.pptx to the new asset paths
- build.py: an Inkscape header (comment before <svg>) or a UTF-8 BOM
  crashed the build of slides 9, 10 and 12. The root is searched for,
  and a file without an <svg> element gives a clear error.
- illustrations.pptx: titles of slides 2-11 and the instructions on slide 1
  still named assets/icons/ and "python build.py"; they now give the
  current folders and config/build.py.

Co-Authored-By: Claude <noreply@anthropic.com>
Claude-Session: https://claude.ai/code/session_01Vb7PS6Yk3Yima81s9SqAcv
</commit_message>
<xml_diff>
--- a/assets/illustrations.pptx
+++ b/assets/illustrations.pptx
@@ -3183,13 +3183,13 @@
           <a:p>
             <a:r>
               <a:rPr sz="1800" b="0"/>
-              <a:t>4. Save it over the file named in the slide title, in the folder assets/icons/ of the presentation.</a:t>
+              <a:t>4. Save it over the file named in the slide title (the path is relative to the presentation folder).</a:t>
             </a:r>
           </a:p>
           <a:p>
             <a:r>
               <a:rPr sz="1800" b="0"/>
-              <a:t>5. Run  python build.py  (or keep  python build.py --watch  running) and refresh the browser.</a:t>
+              <a:t>5. Run  python config/build.py  (or keep  python config/build.py --watch  running) and refresh the browser.</a:t>
             </a:r>
           </a:p>
           <a:p>
@@ -3252,7 +3252,7 @@
           <a:p>
             <a:r>
               <a:rPr sz="2400" b="1"/>
-              <a:t>assets/icons/toc-introduction.svg</a:t>
+              <a:t>assets/03-contents/toc-introduction.svg</a:t>
             </a:r>
           </a:p>
         </p:txBody>
@@ -3336,7 +3336,7 @@
           <a:p>
             <a:r>
               <a:rPr sz="2400" b="1"/>
-              <a:t>assets/icons/toc-physical.svg</a:t>
+              <a:t>assets/03-contents/toc-physical.svg</a:t>
             </a:r>
           </a:p>
         </p:txBody>
@@ -4599,7 +4599,7 @@
           <a:p>
             <a:r>
               <a:rPr sz="2400" b="1"/>
-              <a:t>assets/icons/sota-building.svg</a:t>
+              <a:t>assets/04-introduction/sota-building.svg</a:t>
             </a:r>
           </a:p>
         </p:txBody>
@@ -4988,7 +4988,7 @@
           <a:p>
             <a:r>
               <a:rPr sz="2400" b="1"/>
-              <a:t>assets/icons/sota-material.svg</a:t>
+              <a:t>assets/04-introduction/sota-material.svg</a:t>
             </a:r>
           </a:p>
         </p:txBody>
@@ -5072,7 +5072,7 @@
           <a:p>
             <a:r>
               <a:rPr sz="2400" b="1"/>
-              <a:t>assets/icons/sota-wall.svg</a:t>
+              <a:t>assets/04-introduction/sota-wall.svg</a:t>
             </a:r>
           </a:p>
         </p:txBody>
@@ -5156,7 +5156,7 @@
           <a:p>
             <a:r>
               <a:rPr sz="2400" b="1"/>
-              <a:t>assets/icons/tech-cavities.svg</a:t>
+              <a:t>assets/04-introduction/tech-cavities.svg</a:t>
             </a:r>
           </a:p>
         </p:txBody>
@@ -5240,7 +5240,7 @@
           <a:p>
             <a:r>
               <a:rPr sz="2400" b="1"/>
-              <a:t>assets/icons/tech-lattice.svg</a:t>
+              <a:t>assets/04-introduction/tech-lattice.svg</a:t>
             </a:r>
           </a:p>
         </p:txBody>
@@ -5324,7 +5324,7 @@
           <a:p>
             <a:r>
               <a:rPr sz="2400" b="1"/>
-              <a:t>assets/icons/tech-multimaterial.svg</a:t>
+              <a:t>assets/04-introduction/tech-multimaterial.svg</a:t>
             </a:r>
           </a:p>
         </p:txBody>
@@ -5408,7 +5408,7 @@
           <a:p>
             <a:r>
               <a:rPr sz="2400" b="1"/>
-              <a:t>assets/icons/toc-conclusion.svg</a:t>
+              <a:t>assets/03-contents/toc-conclusion.svg</a:t>
             </a:r>
           </a:p>
         </p:txBody>
@@ -5492,7 +5492,7 @@
           <a:p>
             <a:r>
               <a:rPr sz="2400" b="1"/>
-              <a:t>assets/icons/toc-cosimulation.svg</a:t>
+              <a:t>assets/03-contents/toc-cosimulation.svg</a:t>
             </a:r>
           </a:p>
         </p:txBody>

</xml_diff>

<commit_message>
Drawings of slides 9, 10 and 12: one file per step, stacked (PowerPoint-safe)
The step effects of these drawings relied on classes inside the SVG, which a
PowerPoint export removes. Each step is now a complete drawing in its own
file (governing-*, external-*, internal-*), shown with data-from / data-until
like the radiation slide. The drawings are included inline, so the page font
is used and the build size does not grow. Each file is a slide of
illustrations.pptx (slides 13 to 22).

Co-Authored-By: Claude <noreply@anthropic.com>
Claude-Session: https://claude.ai/code/session_01Vb7PS6Yk3Yima81s9SqAcv
</commit_message>
<xml_diff>
--- a/assets/illustrations.pptx
+++ b/assets/illustrations.pptx
@@ -22,6 +22,11 @@
     <p:sldId id="270" r:id="rId20"/>
     <p:sldId id="271" r:id="rId21"/>
     <p:sldId id="272" r:id="rId22"/>
+    <p:sldId id="273" r:id="rId23"/>
+    <p:sldId id="274" r:id="rId24"/>
+    <p:sldId id="275" r:id="rId25"/>
+    <p:sldId id="276" r:id="rId26"/>
+    <p:sldId id="277" r:id="rId27"/>
   </p:sldIdLst>
   <p:sldSz cx="12192000" cy="6858000"/>
   <p:notesSz cx="6858000" cy="9144000"/>
@@ -4207,14 +4212,14 @@
           <a:p>
             <a:r>
               <a:rPr sz="2400" b="1"/>
-              <a:t>assets/05-physical/governing.svg</a:t>
+              <a:t>assets/05-physical/governing-boundaries-faint.svg</a:t>
             </a:r>
           </a:p>
         </p:txBody>
       </p:sp>
       <p:pic>
         <p:nvPicPr>
-          <p:cNvPr id="3" name="Picture 2" descr="governing.svg"/>
+          <p:cNvPr id="3" name="Picture 2" descr="governing-boundaries-faint.svg"/>
           <p:cNvPicPr>
             <a:picLocks noChangeAspect="1"/>
           </p:cNvPicPr>
@@ -4284,14 +4289,14 @@
           <a:p>
             <a:r>
               <a:rPr sz="2400" b="1"/>
-              <a:t>assets/05-physical/external.svg</a:t>
+              <a:t>assets/05-physical/governing-boundaries-bold.svg</a:t>
             </a:r>
           </a:p>
         </p:txBody>
       </p:sp>
       <p:pic>
         <p:nvPicPr>
-          <p:cNvPr id="3" name="Picture 2" descr="external.svg"/>
+          <p:cNvPr id="3" name="Picture 2" descr="governing-boundaries-bold.svg"/>
           <p:cNvPicPr>
             <a:picLocks noChangeAspect="1"/>
           </p:cNvPicPr>
@@ -4311,8 +4316,8 @@
         </p:blipFill>
         <p:spPr>
           <a:xfrm>
-            <a:off x="3901440" y="1280160"/>
-            <a:ext cx="4389120" cy="5120640"/>
+            <a:off x="4267200" y="1280160"/>
+            <a:ext cx="3657600" cy="5120640"/>
           </a:xfrm>
           <a:prstGeom prst="rect">
             <a:avLst/>
@@ -4328,6 +4333,237 @@
 </file>
 
 <file path=ppt/slides/slide15.xml><?xml version="1.0" encoding="utf-8"?>
+<p:sld xmlns:a="http://schemas.openxmlformats.org/drawingml/2006/main" xmlns:p="http://schemas.openxmlformats.org/presentationml/2006/main" xmlns:r="http://schemas.openxmlformats.org/officeDocument/2006/relationships">
+  <p:cSld>
+    <p:spTree>
+      <p:nvGrpSpPr>
+        <p:cNvPr id="1" name=""/>
+        <p:cNvGrpSpPr/>
+        <p:nvPr/>
+      </p:nvGrpSpPr>
+      <p:grpSpPr/>
+      <p:sp>
+        <p:nvSpPr>
+          <p:cNvPr id="2" name="TextBox 1"/>
+          <p:cNvSpPr txBox="1"/>
+          <p:nvPr/>
+        </p:nvSpPr>
+        <p:spPr>
+          <a:xfrm>
+            <a:off x="457200" y="274320"/>
+            <a:ext cx="10972800" cy="731520"/>
+          </a:xfrm>
+          <a:prstGeom prst="rect">
+            <a:avLst/>
+          </a:prstGeom>
+          <a:noFill/>
+        </p:spPr>
+        <p:txBody>
+          <a:bodyPr wrap="square">
+            <a:spAutoFit/>
+          </a:bodyPr>
+          <a:lstStyle/>
+          <a:p>
+            <a:r>
+              <a:rPr sz="2400" b="1"/>
+              <a:t>assets/05-physical/governing-normals.svg</a:t>
+            </a:r>
+          </a:p>
+        </p:txBody>
+      </p:sp>
+      <p:pic>
+        <p:nvPicPr>
+          <p:cNvPr id="3" name="Picture 2" descr="governing-normals.svg"/>
+          <p:cNvPicPr>
+            <a:picLocks noChangeAspect="1"/>
+          </p:cNvPicPr>
+          <p:nvPr/>
+        </p:nvPicPr>
+        <p:blipFill>
+          <a:blip r:embed="rId2">
+            <a:extLst>
+              <a:ext uri="{96DAC541-7B7A-43D3-8B79-37D633B846F1}">
+                <asvg:svgBlip xmlns:asvg="http://schemas.microsoft.com/office/drawing/2016/SVG/main" r:embed="rId3"/>
+              </a:ext>
+            </a:extLst>
+          </a:blip>
+          <a:stretch>
+            <a:fillRect/>
+          </a:stretch>
+        </p:blipFill>
+        <p:spPr>
+          <a:xfrm>
+            <a:off x="4267200" y="1280160"/>
+            <a:ext cx="3657600" cy="5120640"/>
+          </a:xfrm>
+          <a:prstGeom prst="rect">
+            <a:avLst/>
+          </a:prstGeom>
+        </p:spPr>
+      </p:pic>
+    </p:spTree>
+  </p:cSld>
+  <p:clrMapOvr>
+    <a:masterClrMapping/>
+  </p:clrMapOvr>
+</p:sld>
+</file>
+
+<file path=ppt/slides/slide16.xml><?xml version="1.0" encoding="utf-8"?>
+<p:sld xmlns:a="http://schemas.openxmlformats.org/drawingml/2006/main" xmlns:p="http://schemas.openxmlformats.org/presentationml/2006/main" xmlns:r="http://schemas.openxmlformats.org/officeDocument/2006/relationships">
+  <p:cSld>
+    <p:spTree>
+      <p:nvGrpSpPr>
+        <p:cNvPr id="1" name=""/>
+        <p:cNvGrpSpPr/>
+        <p:nvPr/>
+      </p:nvGrpSpPr>
+      <p:grpSpPr/>
+      <p:sp>
+        <p:nvSpPr>
+          <p:cNvPr id="2" name="TextBox 1"/>
+          <p:cNvSpPr txBox="1"/>
+          <p:nvPr/>
+        </p:nvSpPr>
+        <p:spPr>
+          <a:xfrm>
+            <a:off x="457200" y="274320"/>
+            <a:ext cx="10972800" cy="731520"/>
+          </a:xfrm>
+          <a:prstGeom prst="rect">
+            <a:avLst/>
+          </a:prstGeom>
+          <a:noFill/>
+        </p:spPr>
+        <p:txBody>
+          <a:bodyPr wrap="square">
+            <a:spAutoFit/>
+          </a:bodyPr>
+          <a:lstStyle/>
+          <a:p>
+            <a:r>
+              <a:rPr sz="2400" b="1"/>
+              <a:t>assets/05-physical/external-convection.svg</a:t>
+            </a:r>
+          </a:p>
+        </p:txBody>
+      </p:sp>
+      <p:pic>
+        <p:nvPicPr>
+          <p:cNvPr id="3" name="Picture 2" descr="external-convection.svg"/>
+          <p:cNvPicPr>
+            <a:picLocks noChangeAspect="1"/>
+          </p:cNvPicPr>
+          <p:nvPr/>
+        </p:nvPicPr>
+        <p:blipFill>
+          <a:blip r:embed="rId2">
+            <a:extLst>
+              <a:ext uri="{96DAC541-7B7A-43D3-8B79-37D633B846F1}">
+                <asvg:svgBlip xmlns:asvg="http://schemas.microsoft.com/office/drawing/2016/SVG/main" r:embed="rId3"/>
+              </a:ext>
+            </a:extLst>
+          </a:blip>
+          <a:stretch>
+            <a:fillRect/>
+          </a:stretch>
+        </p:blipFill>
+        <p:spPr>
+          <a:xfrm>
+            <a:off x="3901440" y="1280160"/>
+            <a:ext cx="4389120" cy="5120640"/>
+          </a:xfrm>
+          <a:prstGeom prst="rect">
+            <a:avLst/>
+          </a:prstGeom>
+        </p:spPr>
+      </p:pic>
+    </p:spTree>
+  </p:cSld>
+  <p:clrMapOvr>
+    <a:masterClrMapping/>
+  </p:clrMapOvr>
+</p:sld>
+</file>
+
+<file path=ppt/slides/slide17.xml><?xml version="1.0" encoding="utf-8"?>
+<p:sld xmlns:a="http://schemas.openxmlformats.org/drawingml/2006/main" xmlns:p="http://schemas.openxmlformats.org/presentationml/2006/main" xmlns:r="http://schemas.openxmlformats.org/officeDocument/2006/relationships">
+  <p:cSld>
+    <p:spTree>
+      <p:nvGrpSpPr>
+        <p:cNvPr id="1" name=""/>
+        <p:cNvGrpSpPr/>
+        <p:nvPr/>
+      </p:nvGrpSpPr>
+      <p:grpSpPr/>
+      <p:sp>
+        <p:nvSpPr>
+          <p:cNvPr id="2" name="TextBox 1"/>
+          <p:cNvSpPr txBox="1"/>
+          <p:nvPr/>
+        </p:nvSpPr>
+        <p:spPr>
+          <a:xfrm>
+            <a:off x="457200" y="274320"/>
+            <a:ext cx="10972800" cy="731520"/>
+          </a:xfrm>
+          <a:prstGeom prst="rect">
+            <a:avLst/>
+          </a:prstGeom>
+          <a:noFill/>
+        </p:spPr>
+        <p:txBody>
+          <a:bodyPr wrap="square">
+            <a:spAutoFit/>
+          </a:bodyPr>
+          <a:lstStyle/>
+          <a:p>
+            <a:r>
+              <a:rPr sz="2400" b="1"/>
+              <a:t>assets/05-physical/external-radiation.svg</a:t>
+            </a:r>
+          </a:p>
+        </p:txBody>
+      </p:sp>
+      <p:pic>
+        <p:nvPicPr>
+          <p:cNvPr id="3" name="Picture 2" descr="external-radiation.svg"/>
+          <p:cNvPicPr>
+            <a:picLocks noChangeAspect="1"/>
+          </p:cNvPicPr>
+          <p:nvPr/>
+        </p:nvPicPr>
+        <p:blipFill>
+          <a:blip r:embed="rId2">
+            <a:extLst>
+              <a:ext uri="{96DAC541-7B7A-43D3-8B79-37D633B846F1}">
+                <asvg:svgBlip xmlns:asvg="http://schemas.microsoft.com/office/drawing/2016/SVG/main" r:embed="rId3"/>
+              </a:ext>
+            </a:extLst>
+          </a:blip>
+          <a:stretch>
+            <a:fillRect/>
+          </a:stretch>
+        </p:blipFill>
+        <p:spPr>
+          <a:xfrm>
+            <a:off x="3901440" y="1280160"/>
+            <a:ext cx="4389120" cy="5120640"/>
+          </a:xfrm>
+          <a:prstGeom prst="rect">
+            <a:avLst/>
+          </a:prstGeom>
+        </p:spPr>
+      </p:pic>
+    </p:spTree>
+  </p:cSld>
+  <p:clrMapOvr>
+    <a:masterClrMapping/>
+  </p:clrMapOvr>
+</p:sld>
+</file>
+
+<file path=ppt/slides/slide18.xml><?xml version="1.0" encoding="utf-8"?>
 <p:sld xmlns:a="http://schemas.openxmlformats.org/drawingml/2006/main" xmlns:p="http://schemas.openxmlformats.org/presentationml/2006/main" xmlns:r="http://schemas.openxmlformats.org/officeDocument/2006/relationships">
   <p:cSld>
     <p:spTree>
@@ -4404,7 +4640,7 @@
 </p:sld>
 </file>
 
-<file path=ppt/slides/slide16.xml><?xml version="1.0" encoding="utf-8"?>
+<file path=ppt/slides/slide19.xml><?xml version="1.0" encoding="utf-8"?>
 <p:sld xmlns:a="http://schemas.openxmlformats.org/drawingml/2006/main" xmlns:p="http://schemas.openxmlformats.org/presentationml/2006/main" xmlns:r="http://schemas.openxmlformats.org/officeDocument/2006/relationships">
   <p:cSld>
     <p:spTree>
@@ -4467,83 +4703,6 @@
           <a:xfrm>
             <a:off x="2827506" y="1280160"/>
             <a:ext cx="6536987" cy="5120640"/>
-          </a:xfrm>
-          <a:prstGeom prst="rect">
-            <a:avLst/>
-          </a:prstGeom>
-        </p:spPr>
-      </p:pic>
-    </p:spTree>
-  </p:cSld>
-  <p:clrMapOvr>
-    <a:masterClrMapping/>
-  </p:clrMapOvr>
-</p:sld>
-</file>
-
-<file path=ppt/slides/slide17.xml><?xml version="1.0" encoding="utf-8"?>
-<p:sld xmlns:a="http://schemas.openxmlformats.org/drawingml/2006/main" xmlns:p="http://schemas.openxmlformats.org/presentationml/2006/main" xmlns:r="http://schemas.openxmlformats.org/officeDocument/2006/relationships">
-  <p:cSld>
-    <p:spTree>
-      <p:nvGrpSpPr>
-        <p:cNvPr id="1" name=""/>
-        <p:cNvGrpSpPr/>
-        <p:nvPr/>
-      </p:nvGrpSpPr>
-      <p:grpSpPr/>
-      <p:sp>
-        <p:nvSpPr>
-          <p:cNvPr id="2" name="TextBox 1"/>
-          <p:cNvSpPr txBox="1"/>
-          <p:nvPr/>
-        </p:nvSpPr>
-        <p:spPr>
-          <a:xfrm>
-            <a:off x="457200" y="274320"/>
-            <a:ext cx="10972800" cy="731520"/>
-          </a:xfrm>
-          <a:prstGeom prst="rect">
-            <a:avLst/>
-          </a:prstGeom>
-          <a:noFill/>
-        </p:spPr>
-        <p:txBody>
-          <a:bodyPr wrap="square">
-            <a:spAutoFit/>
-          </a:bodyPr>
-          <a:lstStyle/>
-          <a:p>
-            <a:r>
-              <a:rPr sz="2400" b="1"/>
-              <a:t>assets/05-physical/internal.svg</a:t>
-            </a:r>
-          </a:p>
-        </p:txBody>
-      </p:sp>
-      <p:pic>
-        <p:nvPicPr>
-          <p:cNvPr id="3" name="Picture 2" descr="internal.svg"/>
-          <p:cNvPicPr>
-            <a:picLocks noChangeAspect="1"/>
-          </p:cNvPicPr>
-          <p:nvPr/>
-        </p:nvPicPr>
-        <p:blipFill>
-          <a:blip r:embed="rId2">
-            <a:extLst>
-              <a:ext uri="{96DAC541-7B7A-43D3-8B79-37D633B846F1}">
-                <asvg:svgBlip xmlns:asvg="http://schemas.microsoft.com/office/drawing/2016/SVG/main" r:embed="rId3"/>
-              </a:ext>
-            </a:extLst>
-          </a:blip>
-          <a:stretch>
-            <a:fillRect/>
-          </a:stretch>
-        </p:blipFill>
-        <p:spPr>
-          <a:xfrm>
-            <a:off x="3580598" y="1280160"/>
-            <a:ext cx="5030804" cy="5120640"/>
           </a:xfrm>
           <a:prstGeom prst="rect">
             <a:avLst/>
@@ -4939,6 +5098,237 @@
           </a:p>
         </p:txBody>
       </p:sp>
+    </p:spTree>
+  </p:cSld>
+  <p:clrMapOvr>
+    <a:masterClrMapping/>
+  </p:clrMapOvr>
+</p:sld>
+</file>
+
+<file path=ppt/slides/slide20.xml><?xml version="1.0" encoding="utf-8"?>
+<p:sld xmlns:a="http://schemas.openxmlformats.org/drawingml/2006/main" xmlns:p="http://schemas.openxmlformats.org/presentationml/2006/main" xmlns:r="http://schemas.openxmlformats.org/officeDocument/2006/relationships">
+  <p:cSld>
+    <p:spTree>
+      <p:nvGrpSpPr>
+        <p:cNvPr id="1" name=""/>
+        <p:cNvGrpSpPr/>
+        <p:nvPr/>
+      </p:nvGrpSpPr>
+      <p:grpSpPr/>
+      <p:sp>
+        <p:nvSpPr>
+          <p:cNvPr id="2" name="TextBox 1"/>
+          <p:cNvSpPr txBox="1"/>
+          <p:nvPr/>
+        </p:nvSpPr>
+        <p:spPr>
+          <a:xfrm>
+            <a:off x="457200" y="274320"/>
+            <a:ext cx="10972800" cy="731520"/>
+          </a:xfrm>
+          <a:prstGeom prst="rect">
+            <a:avLst/>
+          </a:prstGeom>
+          <a:noFill/>
+        </p:spPr>
+        <p:txBody>
+          <a:bodyPr wrap="square">
+            <a:spAutoFit/>
+          </a:bodyPr>
+          <a:lstStyle/>
+          <a:p>
+            <a:r>
+              <a:rPr sz="2400" b="1"/>
+              <a:t>assets/05-physical/internal-convection.svg</a:t>
+            </a:r>
+          </a:p>
+        </p:txBody>
+      </p:sp>
+      <p:pic>
+        <p:nvPicPr>
+          <p:cNvPr id="3" name="Picture 2" descr="internal-convection.svg"/>
+          <p:cNvPicPr>
+            <a:picLocks noChangeAspect="1"/>
+          </p:cNvPicPr>
+          <p:nvPr/>
+        </p:nvPicPr>
+        <p:blipFill>
+          <a:blip r:embed="rId2">
+            <a:extLst>
+              <a:ext uri="{96DAC541-7B7A-43D3-8B79-37D633B846F1}">
+                <asvg:svgBlip xmlns:asvg="http://schemas.microsoft.com/office/drawing/2016/SVG/main" r:embed="rId3"/>
+              </a:ext>
+            </a:extLst>
+          </a:blip>
+          <a:stretch>
+            <a:fillRect/>
+          </a:stretch>
+        </p:blipFill>
+        <p:spPr>
+          <a:xfrm>
+            <a:off x="3580598" y="1280160"/>
+            <a:ext cx="5030804" cy="5120640"/>
+          </a:xfrm>
+          <a:prstGeom prst="rect">
+            <a:avLst/>
+          </a:prstGeom>
+        </p:spPr>
+      </p:pic>
+    </p:spTree>
+  </p:cSld>
+  <p:clrMapOvr>
+    <a:masterClrMapping/>
+  </p:clrMapOvr>
+</p:sld>
+</file>
+
+<file path=ppt/slides/slide21.xml><?xml version="1.0" encoding="utf-8"?>
+<p:sld xmlns:a="http://schemas.openxmlformats.org/drawingml/2006/main" xmlns:p="http://schemas.openxmlformats.org/presentationml/2006/main" xmlns:r="http://schemas.openxmlformats.org/officeDocument/2006/relationships">
+  <p:cSld>
+    <p:spTree>
+      <p:nvGrpSpPr>
+        <p:cNvPr id="1" name=""/>
+        <p:cNvGrpSpPr/>
+        <p:nvPr/>
+      </p:nvGrpSpPr>
+      <p:grpSpPr/>
+      <p:sp>
+        <p:nvSpPr>
+          <p:cNvPr id="2" name="TextBox 1"/>
+          <p:cNvSpPr txBox="1"/>
+          <p:nvPr/>
+        </p:nvSpPr>
+        <p:spPr>
+          <a:xfrm>
+            <a:off x="457200" y="274320"/>
+            <a:ext cx="10972800" cy="731520"/>
+          </a:xfrm>
+          <a:prstGeom prst="rect">
+            <a:avLst/>
+          </a:prstGeom>
+          <a:noFill/>
+        </p:spPr>
+        <p:txBody>
+          <a:bodyPr wrap="square">
+            <a:spAutoFit/>
+          </a:bodyPr>
+          <a:lstStyle/>
+          <a:p>
+            <a:r>
+              <a:rPr sz="2400" b="1"/>
+              <a:t>assets/05-physical/internal-longwave.svg</a:t>
+            </a:r>
+          </a:p>
+        </p:txBody>
+      </p:sp>
+      <p:pic>
+        <p:nvPicPr>
+          <p:cNvPr id="3" name="Picture 2" descr="internal-longwave.svg"/>
+          <p:cNvPicPr>
+            <a:picLocks noChangeAspect="1"/>
+          </p:cNvPicPr>
+          <p:nvPr/>
+        </p:nvPicPr>
+        <p:blipFill>
+          <a:blip r:embed="rId2">
+            <a:extLst>
+              <a:ext uri="{96DAC541-7B7A-43D3-8B79-37D633B846F1}">
+                <asvg:svgBlip xmlns:asvg="http://schemas.microsoft.com/office/drawing/2016/SVG/main" r:embed="rId3"/>
+              </a:ext>
+            </a:extLst>
+          </a:blip>
+          <a:stretch>
+            <a:fillRect/>
+          </a:stretch>
+        </p:blipFill>
+        <p:spPr>
+          <a:xfrm>
+            <a:off x="3580598" y="1280160"/>
+            <a:ext cx="5030804" cy="5120640"/>
+          </a:xfrm>
+          <a:prstGeom prst="rect">
+            <a:avLst/>
+          </a:prstGeom>
+        </p:spPr>
+      </p:pic>
+    </p:spTree>
+  </p:cSld>
+  <p:clrMapOvr>
+    <a:masterClrMapping/>
+  </p:clrMapOvr>
+</p:sld>
+</file>
+
+<file path=ppt/slides/slide22.xml><?xml version="1.0" encoding="utf-8"?>
+<p:sld xmlns:a="http://schemas.openxmlformats.org/drawingml/2006/main" xmlns:p="http://schemas.openxmlformats.org/presentationml/2006/main" xmlns:r="http://schemas.openxmlformats.org/officeDocument/2006/relationships">
+  <p:cSld>
+    <p:spTree>
+      <p:nvGrpSpPr>
+        <p:cNvPr id="1" name=""/>
+        <p:cNvGrpSpPr/>
+        <p:nvPr/>
+      </p:nvGrpSpPr>
+      <p:grpSpPr/>
+      <p:sp>
+        <p:nvSpPr>
+          <p:cNvPr id="2" name="TextBox 1"/>
+          <p:cNvSpPr txBox="1"/>
+          <p:nvPr/>
+        </p:nvSpPr>
+        <p:spPr>
+          <a:xfrm>
+            <a:off x="457200" y="274320"/>
+            <a:ext cx="10972800" cy="731520"/>
+          </a:xfrm>
+          <a:prstGeom prst="rect">
+            <a:avLst/>
+          </a:prstGeom>
+          <a:noFill/>
+        </p:spPr>
+        <p:txBody>
+          <a:bodyPr wrap="square">
+            <a:spAutoFit/>
+          </a:bodyPr>
+          <a:lstStyle/>
+          <a:p>
+            <a:r>
+              <a:rPr sz="2400" b="1"/>
+              <a:t>assets/05-physical/internal-adiabatic.svg</a:t>
+            </a:r>
+          </a:p>
+        </p:txBody>
+      </p:sp>
+      <p:pic>
+        <p:nvPicPr>
+          <p:cNvPr id="3" name="Picture 2" descr="internal-adiabatic.svg"/>
+          <p:cNvPicPr>
+            <a:picLocks noChangeAspect="1"/>
+          </p:cNvPicPr>
+          <p:nvPr/>
+        </p:nvPicPr>
+        <p:blipFill>
+          <a:blip r:embed="rId2">
+            <a:extLst>
+              <a:ext uri="{96DAC541-7B7A-43D3-8B79-37D633B846F1}">
+                <asvg:svgBlip xmlns:asvg="http://schemas.microsoft.com/office/drawing/2016/SVG/main" r:embed="rId3"/>
+              </a:ext>
+            </a:extLst>
+          </a:blip>
+          <a:stretch>
+            <a:fillRect/>
+          </a:stretch>
+        </p:blipFill>
+        <p:spPr>
+          <a:xfrm>
+            <a:off x="3580598" y="1280160"/>
+            <a:ext cx="5030804" cy="5120640"/>
+          </a:xfrm>
+          <a:prstGeom prst="rect">
+            <a:avLst/>
+          </a:prstGeom>
+        </p:spPr>
+      </p:pic>
     </p:spTree>
   </p:cSld>
   <p:clrMapOvr>

</xml_diff>

<commit_message>
Slide 5: the three schemas are SVG files (editable in illustrations.pptx) instead of JS-drawn
Pixel-identical to the previous slide; the clip path of the old drawing is now an explicit shape so that PowerPoint keeps it.

Co-Authored-By: Claude Sonnet 5.5 <noreply@anthropic.com>
Claude-Session: https://claude.ai/code/session_01Vb7PS6Yk3Yima81s9SqAcv
</commit_message>
<xml_diff>
--- a/assets/illustrations.pptx
+++ b/assets/illustrations.pptx
@@ -28,6 +28,9 @@
     <p:sldId id="276" r:id="rId26"/>
     <p:sldId id="277" r:id="rId27"/>
     <p:sldId id="278" r:id="rId28"/>
+    <p:sldId id="279" r:id="rId29"/>
+    <p:sldId id="280" r:id="rId30"/>
+    <p:sldId id="281" r:id="rId31"/>
   </p:sldIdLst>
   <p:sldSz cx="12192000" cy="6858000"/>
   <p:notesSz cx="6858000" cy="9144000"/>
@@ -5401,6 +5404,237 @@
           <a:xfrm>
             <a:off x="3029435" y="1280160"/>
             <a:ext cx="6133130" cy="5120640"/>
+          </a:xfrm>
+          <a:prstGeom prst="rect">
+            <a:avLst/>
+          </a:prstGeom>
+        </p:spPr>
+      </p:pic>
+    </p:spTree>
+  </p:cSld>
+  <p:clrMapOvr>
+    <a:masterClrMapping/>
+  </p:clrMapOvr>
+</p:sld>
+</file>
+
+<file path=ppt/slides/slide24.xml><?xml version="1.0" encoding="utf-8"?>
+<p:sld xmlns:a="http://schemas.openxmlformats.org/drawingml/2006/main" xmlns:p="http://schemas.openxmlformats.org/presentationml/2006/main" xmlns:r="http://schemas.openxmlformats.org/officeDocument/2006/relationships">
+  <p:cSld>
+    <p:spTree>
+      <p:nvGrpSpPr>
+        <p:cNvPr id="1" name=""/>
+        <p:cNvGrpSpPr/>
+        <p:nvPr/>
+      </p:nvGrpSpPr>
+      <p:grpSpPr/>
+      <p:sp>
+        <p:nvSpPr>
+          <p:cNvPr id="2" name="TextBox 1"/>
+          <p:cNvSpPr txBox="1"/>
+          <p:nvPr/>
+        </p:nvSpPr>
+        <p:spPr>
+          <a:xfrm>
+            <a:off x="457200" y="274320"/>
+            <a:ext cx="10972800" cy="731520"/>
+          </a:xfrm>
+          <a:prstGeom prst="rect">
+            <a:avLst/>
+          </a:prstGeom>
+          <a:noFill/>
+        </p:spPr>
+        <p:txBody>
+          <a:bodyPr wrap="square">
+            <a:spAutoFit/>
+          </a:bodyPr>
+          <a:lstStyle/>
+          <a:p>
+            <a:r>
+              <a:rPr sz="2400" b="1"/>
+              <a:t>assets/04-introduction/why-topology.svg</a:t>
+            </a:r>
+          </a:p>
+        </p:txBody>
+      </p:sp>
+      <p:pic>
+        <p:nvPicPr>
+          <p:cNvPr id="3" name="Picture 2" descr="why-topology.svg"/>
+          <p:cNvPicPr>
+            <a:picLocks noChangeAspect="1"/>
+          </p:cNvPicPr>
+          <p:nvPr/>
+        </p:nvPicPr>
+        <p:blipFill>
+          <a:blip r:embed="rId2">
+            <a:extLst>
+              <a:ext uri="{96DAC541-7B7A-43D3-8B79-37D633B846F1}">
+                <asvg:svgBlip xmlns:asvg="http://schemas.microsoft.com/office/drawing/2016/SVG/main" r:embed="rId3"/>
+              </a:ext>
+            </a:extLst>
+          </a:blip>
+          <a:stretch>
+            <a:fillRect/>
+          </a:stretch>
+        </p:blipFill>
+        <p:spPr>
+          <a:xfrm>
+            <a:off x="2095500" y="1280160"/>
+            <a:ext cx="8001000" cy="5049981"/>
+          </a:xfrm>
+          <a:prstGeom prst="rect">
+            <a:avLst/>
+          </a:prstGeom>
+        </p:spPr>
+      </p:pic>
+    </p:spTree>
+  </p:cSld>
+  <p:clrMapOvr>
+    <a:masterClrMapping/>
+  </p:clrMapOvr>
+</p:sld>
+</file>
+
+<file path=ppt/slides/slide25.xml><?xml version="1.0" encoding="utf-8"?>
+<p:sld xmlns:a="http://schemas.openxmlformats.org/drawingml/2006/main" xmlns:p="http://schemas.openxmlformats.org/presentationml/2006/main" xmlns:r="http://schemas.openxmlformats.org/officeDocument/2006/relationships">
+  <p:cSld>
+    <p:spTree>
+      <p:nvGrpSpPr>
+        <p:cNvPr id="1" name=""/>
+        <p:cNvGrpSpPr/>
+        <p:nvPr/>
+      </p:nvGrpSpPr>
+      <p:grpSpPr/>
+      <p:sp>
+        <p:nvSpPr>
+          <p:cNvPr id="2" name="TextBox 1"/>
+          <p:cNvSpPr txBox="1"/>
+          <p:nvPr/>
+        </p:nvSpPr>
+        <p:spPr>
+          <a:xfrm>
+            <a:off x="457200" y="274320"/>
+            <a:ext cx="10972800" cy="731520"/>
+          </a:xfrm>
+          <a:prstGeom prst="rect">
+            <a:avLst/>
+          </a:prstGeom>
+          <a:noFill/>
+        </p:spPr>
+        <p:txBody>
+          <a:bodyPr wrap="square">
+            <a:spAutoFit/>
+          </a:bodyPr>
+          <a:lstStyle/>
+          <a:p>
+            <a:r>
+              <a:rPr sz="2400" b="1"/>
+              <a:t>assets/04-introduction/why-shape.svg</a:t>
+            </a:r>
+          </a:p>
+        </p:txBody>
+      </p:sp>
+      <p:pic>
+        <p:nvPicPr>
+          <p:cNvPr id="3" name="Picture 2" descr="why-shape.svg"/>
+          <p:cNvPicPr>
+            <a:picLocks noChangeAspect="1"/>
+          </p:cNvPicPr>
+          <p:nvPr/>
+        </p:nvPicPr>
+        <p:blipFill>
+          <a:blip r:embed="rId2">
+            <a:extLst>
+              <a:ext uri="{96DAC541-7B7A-43D3-8B79-37D633B846F1}">
+                <asvg:svgBlip xmlns:asvg="http://schemas.microsoft.com/office/drawing/2016/SVG/main" r:embed="rId3"/>
+              </a:ext>
+            </a:extLst>
+          </a:blip>
+          <a:stretch>
+            <a:fillRect/>
+          </a:stretch>
+        </p:blipFill>
+        <p:spPr>
+          <a:xfrm>
+            <a:off x="2095500" y="1280160"/>
+            <a:ext cx="8001000" cy="5049981"/>
+          </a:xfrm>
+          <a:prstGeom prst="rect">
+            <a:avLst/>
+          </a:prstGeom>
+        </p:spPr>
+      </p:pic>
+    </p:spTree>
+  </p:cSld>
+  <p:clrMapOvr>
+    <a:masterClrMapping/>
+  </p:clrMapOvr>
+</p:sld>
+</file>
+
+<file path=ppt/slides/slide26.xml><?xml version="1.0" encoding="utf-8"?>
+<p:sld xmlns:a="http://schemas.openxmlformats.org/drawingml/2006/main" xmlns:p="http://schemas.openxmlformats.org/presentationml/2006/main" xmlns:r="http://schemas.openxmlformats.org/officeDocument/2006/relationships">
+  <p:cSld>
+    <p:spTree>
+      <p:nvGrpSpPr>
+        <p:cNvPr id="1" name=""/>
+        <p:cNvGrpSpPr/>
+        <p:nvPr/>
+      </p:nvGrpSpPr>
+      <p:grpSpPr/>
+      <p:sp>
+        <p:nvSpPr>
+          <p:cNvPr id="2" name="TextBox 1"/>
+          <p:cNvSpPr txBox="1"/>
+          <p:nvPr/>
+        </p:nvSpPr>
+        <p:spPr>
+          <a:xfrm>
+            <a:off x="457200" y="274320"/>
+            <a:ext cx="10972800" cy="731520"/>
+          </a:xfrm>
+          <a:prstGeom prst="rect">
+            <a:avLst/>
+          </a:prstGeom>
+          <a:noFill/>
+        </p:spPr>
+        <p:txBody>
+          <a:bodyPr wrap="square">
+            <a:spAutoFit/>
+          </a:bodyPr>
+          <a:lstStyle/>
+          <a:p>
+            <a:r>
+              <a:rPr sz="2400" b="1"/>
+              <a:t>assets/04-introduction/why-both.svg</a:t>
+            </a:r>
+          </a:p>
+        </p:txBody>
+      </p:sp>
+      <p:pic>
+        <p:nvPicPr>
+          <p:cNvPr id="3" name="Picture 2" descr="why-both.svg"/>
+          <p:cNvPicPr>
+            <a:picLocks noChangeAspect="1"/>
+          </p:cNvPicPr>
+          <p:nvPr/>
+        </p:nvPicPr>
+        <p:blipFill>
+          <a:blip r:embed="rId2">
+            <a:extLst>
+              <a:ext uri="{96DAC541-7B7A-43D3-8B79-37D633B846F1}">
+                <asvg:svgBlip xmlns:asvg="http://schemas.microsoft.com/office/drawing/2016/SVG/main" r:embed="rId3"/>
+              </a:ext>
+            </a:extLst>
+          </a:blip>
+          <a:stretch>
+            <a:fillRect/>
+          </a:stretch>
+        </p:blipFill>
+        <p:spPr>
+          <a:xfrm>
+            <a:off x="2095500" y="1280160"/>
+            <a:ext cx="8001000" cy="5049981"/>
           </a:xfrm>
           <a:prstGeom prst="rect">
             <a:avLst/>

</xml_diff>